<commit_message>
feat(showcase): refresh review deck at latest baseline f81ca20 (#265)
Recapture the mobile import/report screens at origin/main f81ca20 after #274/#295 landed, rebuild the 10-page deck, and refresh capture provenance, deck QA and delivery hashes.
</commit_message>
<xml_diff>
--- a/showcase/privacytrace-review/delivery/PrivacyTrace-Review.pptx
+++ b/showcase/privacytrace-review/delivery/PrivacyTrace-Review.pptx
@@ -581,7 +581,7 @@
           <a:lstStyle/>
           <a:p>
             <a:r>
-              <a:t>附录把视频、PPT、界面采集、源文件、哈希、提交绑定和复核命令放在一起。界面图采集于 2026-10-23，提交 dc2eee0，来源清单在 capture/manifest.json。提交状态以报名系统为准，本页只固定材料版本与哈希。</a:t>
+              <a:t>附录把视频、PPT、界面采集、源文件、哈希、提交绑定和复核命令放在一起。界面图采集于 2026-10-23，提交 f81ca20，来源清单在 capture/manifest.json。提交状态以报名系统为准，本页只固定材料版本与哈希。</a:t>
             </a:r>
           </a:p>
         </p:txBody>
@@ -651,7 +651,7 @@
           <a:lstStyle/>
           <a:p>
             <a:r>
-              <a:t>定位：它读取安装包里的静态线索，和政策原文逐条对照。权限是能力，invoke 是线索，两者都不等于实际采集。右侧是 2026-10-23 采集的移动 App 开发版截图（提交 dc2eee0），固定合成材料；截图来自生产 Vue + 受控 native bridge，不是真机，也不是 APK 扫描。桌面工作台按 ADR-0005 冻结，不是客户端。</a:t>
+              <a:t>定位：它读取安装包里的静态线索，和政策原文逐条对照。权限是能力，invoke 是线索，两者都不等于实际采集。右侧是 2026-10-23 采集的移动 App 开发版截图（提交 f81ca20），固定合成材料；截图来自生产 Vue + 受控 native bridge，不是真机，也不是 APK 扫描。桌面工作台按 ADR-0005 冻结，不是客户端。</a:t>
             </a:r>
           </a:p>
         </p:txBody>
@@ -791,7 +791,7 @@
           <a:lstStyle/>
           <a:p>
             <a:r>
-              <a:t>实现是一条流水线：材料进来，隔离容器里解析，生成证据和候选，一致性引擎对照，最后出报告和回放。左边四个块是可核的约束和组件；右侧是 2026-10-23 采集的移动报告（提交 dc2eee0），输入是构造材料，页面是持久化回放，两条结论都待复核。界面仍是开发版，最终视觉可能变化。</a:t>
+              <a:t>实现是一条流水线：材料进来，隔离容器里解析，生成证据和候选，一致性引擎对照，最后出报告和回放。左边四个块是可核的约束和组件；右侧是 2026-10-23 采集的移动报告（提交 f81ca20），输入是构造材料，页面是持久化回放，两条结论都待复核。界面仍是开发版，最终视觉可能变化。</a:t>
             </a:r>
           </a:p>
         </p:txBody>
@@ -7112,7 +7112,7 @@
                 <a:latin typeface="Noto Sans SC"/>
                 <a:ea typeface="Noto Sans SC"/>
               </a:rPr>
-              <a:t>移动 App · 2026-10-23 · 390×844 DPR 3 @ dc2eee0 · capture/manifest.json</a:t>
+              <a:t>移动 App · 2026-10-23 · 390×844 DPR 3 @ f81ca20 · capture/manifest.json</a:t>
             </a:r>
           </a:p>
         </p:txBody>
@@ -9379,7 +9379,7 @@
                 <a:latin typeface="Cascadia Mono"/>
                 <a:ea typeface="Cascadia Mono"/>
               </a:rPr>
-              <a:t>2026-10-23 采集 @ dc2eee0</a:t>
+              <a:t>2026-10-23 采集 @ f81ca20</a:t>
             </a:r>
           </a:p>
         </p:txBody>
@@ -9665,7 +9665,7 @@
                 <a:latin typeface="Noto Sans SC"/>
                 <a:ea typeface="Noto Sans SC"/>
               </a:rPr>
-              <a:t>选择应用并上传</a:t>
+              <a:t>选择应用</a:t>
             </a:r>
           </a:p>
         </p:txBody>
@@ -14117,7 +14117,7 @@
                 <a:latin typeface="Cascadia Mono"/>
                 <a:ea typeface="Cascadia Mono"/>
               </a:rPr>
-              <a:t>2026-10-23 采集 @ dc2eee0</a:t>
+              <a:t>2026-10-23 采集 @ f81ca20</a:t>
             </a:r>
           </a:p>
         </p:txBody>

</xml_diff>